<commit_message>
Azure soak-test follow-ups: F03 relabel, F10 search by trail name, doc and deck updates
- F03: gr-0004 relabeled mixed; gpt-4.1 10/10 on both sets, llama3.2
  stand-in 8/10 hard; expected-output, track docs, M1 outline and deck
  notes updated
- F10: search_trails keywords match trail names (dotnet/python/ts,
  tool-definitions.json, azure.http) so Avalanche Lake is reachable by
  name; rationale in lab, expected-output, http comments, M4 notes
- F10: document rain-day spread seen in soak runs; rebuild M4 deck

Co-Authored-By: Claude Fable 5.1 <noreply@anthropic.com>
</commit_message>
<xml_diff>
--- a/docs/slides/pptx/M4-doing.pptx
+++ b/docs/slides/pptx/M4-doing.pptx
@@ -3309,7 +3309,16 @@
               <a:t>dotnet/F10-dotnet.md</a:t>
             </a:r>
             <a:r>
-              <a:t>. The reliability story, spoken over the scrolling trace: local </a:t>
+              <a:t>. Soak-tested 2026-09-03, 10 of 10 on both the default and the washout request. Two things the room may see: the rain day sometimes gets a moderate hike rather than an easy one (3 of 10 runs, the hard hike still lands on a dry day; say "it shaped the plan, it didn't perfect it"), and </a:t>
+            </a:r>
+            <a:r>
+              <a:rPr>
+                <a:latin typeface="Consolas"/>
+              </a:rPr>
+              <a:t>search_trails</a:t>
+            </a:r>
+            <a:r>
+              <a:t> keywords match trail names on purpose, because Avalanche Lake sits past the 8-result cap and without the name match the agent cannot reach it. If the agent ever says it could not find the trail, that is the tool's fault, not the model's, and it is a better lesson than the bridge. The reliability story, spoken over the scrolling trace: local </a:t>
             </a:r>
             <a:r>
               <a:rPr>

</xml_diff>

<commit_message>
Humanizer pass over the soak-test prose additions; rebuild M4 deck
Co-Authored-By: Claude Fable 5.1 <noreply@anthropic.com>
</commit_message>
<xml_diff>
--- a/docs/slides/pptx/M4-doing.pptx
+++ b/docs/slides/pptx/M4-doing.pptx
@@ -3318,7 +3318,7 @@
               <a:t>search_trails</a:t>
             </a:r>
             <a:r>
-              <a:t> keywords match trail names on purpose, because Avalanche Lake sits past the 8-result cap and without the name match the agent cannot reach it. If the agent ever says it could not find the trail, that is the tool's fault, not the model's, and it is a better lesson than the bridge. The reliability story, spoken over the scrolling trace: local </a:t>
+              <a:t> keywords match trail names on purpose, because Avalanche Lake sits past the 8-result cap and without the name match the agent cannot reach it. If the agent ever says it could not find the trail, the search tool is the reason, and that makes a better lesson than the bridge. The reliability story, spoken over the scrolling trace: local </a:t>
             </a:r>
             <a:r>
               <a:rPr>
@@ -3327,7 +3327,7 @@
               <a:t>llama3.2</a:t>
             </a:r>
             <a:r>
-              <a:t> across ~two dozen runs called a tool with the literal argument "[insert trail IDs here]", announced it had called every tool then wrote nothing, emitted tool calls as plain text so none executed, and read "bridge is OUT" and scheduled the trail anyway — fewer than one run in five reached all four planning tools before scaffolding. That is why this is the one feature of the day that pays for a frontier model, and why the guardrails aren't optional: a malformed call breaks the loop, not the answer.</a:t>
+              <a:t> across ~two dozen runs called a tool with the literal argument "[insert trail IDs here]", announced it had called every tool then wrote nothing, emitted tool calls as plain text so none executed, and read "bridge is OUT" and scheduled the trail anyway. Fewer than one run in five reached all four planning tools before scaffolding. That is why this is the one feature of the day that pays for a frontier model, and why the guardrails aren't optional: a malformed call breaks the loop, not the answer.</a:t>
             </a:r>
           </a:p>
           <a:p>

</xml_diff>